<commit_message>
update case study 1, added uhn lung cohort
</commit_message>
<xml_diff>
--- a/figures/Figure5_case4.pptx
+++ b/figures/Figure5_case4.pptx
@@ -11929,6 +11929,36 @@
       </p:grpSpPr>
       <p:pic>
         <p:nvPicPr>
+          <p:cNvPr id="37" name="Picture 36">
+            <a:extLst>
+              <a:ext uri="{FF2B5EF4-FFF2-40B4-BE49-F238E27FC236}">
+                <a16:creationId xmlns:a16="http://schemas.microsoft.com/office/drawing/2014/main" id="{24A3C73E-E816-E8B2-6DC7-F15F1862A456}"/>
+              </a:ext>
+            </a:extLst>
+          </p:cNvPr>
+          <p:cNvPicPr>
+            <a:picLocks noChangeAspect="1"/>
+          </p:cNvPicPr>
+          <p:nvPr/>
+        </p:nvPicPr>
+        <p:blipFill>
+          <a:blip r:embed="rId3"/>
+          <a:stretch>
+            <a:fillRect/>
+          </a:stretch>
+        </p:blipFill>
+        <p:spPr>
+          <a:xfrm>
+            <a:off x="10532883" y="2755440"/>
+            <a:ext cx="2940976" cy="2420449"/>
+          </a:xfrm>
+          <a:prstGeom prst="rect">
+            <a:avLst/>
+          </a:prstGeom>
+        </p:spPr>
+      </p:pic>
+      <p:pic>
+        <p:nvPicPr>
           <p:cNvPr id="29" name="Picture 28">
             <a:extLst>
               <a:ext uri="{FF2B5EF4-FFF2-40B4-BE49-F238E27FC236}">
@@ -11942,7 +11972,7 @@
           <p:nvPr/>
         </p:nvPicPr>
         <p:blipFill>
-          <a:blip r:embed="rId3"/>
+          <a:blip r:embed="rId4"/>
           <a:stretch>
             <a:fillRect/>
           </a:stretch>
@@ -11972,15 +12002,15 @@
           <p:nvPr/>
         </p:nvPicPr>
         <p:blipFill>
-          <a:blip r:embed="rId4"/>
+          <a:blip r:embed="rId5"/>
           <a:stretch>
             <a:fillRect/>
           </a:stretch>
         </p:blipFill>
         <p:spPr>
           <a:xfrm>
-            <a:off x="-25532" y="0"/>
-            <a:ext cx="3376318" cy="5191968"/>
+            <a:off x="164390" y="77789"/>
+            <a:ext cx="3217106" cy="4947138"/>
           </a:xfrm>
           <a:prstGeom prst="rect">
             <a:avLst/>
@@ -12198,7 +12228,7 @@
             <a:r>
               <a:rPr lang="en-CA" sz="1800" dirty="0">
                 <a:solidFill>
-                  <a:schemeClr val="dk1"/>
+                  <a:schemeClr val="tx1"/>
                 </a:solidFill>
                 <a:latin typeface="Arial"/>
                 <a:ea typeface="Arial"/>
@@ -12207,7 +12237,11 @@
               </a:rPr>
               <a:t>d.</a:t>
             </a:r>
-            <a:endParaRPr dirty="0"/>
+            <a:endParaRPr dirty="0">
+              <a:solidFill>
+                <a:schemeClr val="tx1"/>
+              </a:solidFill>
+            </a:endParaRPr>
           </a:p>
         </p:txBody>
       </p:sp>
@@ -12226,7 +12260,7 @@
           <p:nvPr/>
         </p:nvPicPr>
         <p:blipFill>
-          <a:blip r:embed="rId5"/>
+          <a:blip r:embed="rId6"/>
           <a:stretch>
             <a:fillRect/>
           </a:stretch>
@@ -12235,36 +12269,6 @@
           <a:xfrm>
             <a:off x="3632410" y="460433"/>
             <a:ext cx="6453344" cy="4635500"/>
-          </a:xfrm>
-          <a:prstGeom prst="rect">
-            <a:avLst/>
-          </a:prstGeom>
-        </p:spPr>
-      </p:pic>
-      <p:pic>
-        <p:nvPicPr>
-          <p:cNvPr id="37" name="Picture 36">
-            <a:extLst>
-              <a:ext uri="{FF2B5EF4-FFF2-40B4-BE49-F238E27FC236}">
-                <a16:creationId xmlns:a16="http://schemas.microsoft.com/office/drawing/2014/main" id="{24A3C73E-E816-E8B2-6DC7-F15F1862A456}"/>
-              </a:ext>
-            </a:extLst>
-          </p:cNvPr>
-          <p:cNvPicPr>
-            <a:picLocks noChangeAspect="1"/>
-          </p:cNvPicPr>
-          <p:nvPr/>
-        </p:nvPicPr>
-        <p:blipFill>
-          <a:blip r:embed="rId6"/>
-          <a:stretch>
-            <a:fillRect/>
-          </a:stretch>
-        </p:blipFill>
-        <p:spPr>
-          <a:xfrm>
-            <a:off x="10532883" y="2755440"/>
-            <a:ext cx="2940976" cy="2420449"/>
           </a:xfrm>
           <a:prstGeom prst="rect">
             <a:avLst/>

</xml_diff>